<commit_message>
Add shared slide theme + finalize deck footer (name, COMSATS, page number)
- New slides/generators/theme.js: shared palette, fonts, and slide-building
  helpers (kicker, title, numCircle, card, callout, codeBox, table styles,
  screenshotFrame) extracted from the Lecture 1 generator, so every future
  lecture deck imports the same design system instead of redefining it
- Finalized the footer used on every slide: "Usman Akram  |  COMSATS
  University Islamabad" + slide number, in both light and dark variants;
  applied it to the title and closing slides too (previously footer-less)
- Regenerated the Lecture 1 deck with the new footer; re-validated

Co-Authored-By: Claude Sonnet 5 <noreply@anthropic.com>
</commit_message>
<xml_diff>
--- a/slides/CSC336-Lecture-01-Introduction-to-Web-Development.pptx
+++ b/slides/CSC336-Lecture-01-Introduction-to-Web-Development.pptx
@@ -2529,9 +2529,87 @@
                 <a:ea typeface="Calibri" pitchFamily="34" charset="-122"/>
                 <a:cs typeface="Calibri" pitchFamily="34" charset="-120"/>
               </a:rPr>
-              <a:t>CSC336 Web Technologies  •  COMSATS University Islamabad</a:t>
+              <a:t>CSC336 Web Technologies</a:t>
             </a:r>
             <a:endParaRPr lang="en-US" sz="1200" dirty="0"/>
+          </a:p>
+        </p:txBody>
+      </p:sp>
+      <p:sp>
+        <p:nvSpPr>
+          <p:cNvPr id="12" name="Text 10"/>
+          <p:cNvSpPr txBox="1"/>
+          <p:nvPr/>
+        </p:nvSpPr>
+        <p:spPr>
+          <a:xfrm>
+            <a:off x="640080" y="6446520"/>
+            <a:ext cx="8686800" cy="292608"/>
+          </a:xfrm>
+          <a:prstGeom prst="rect">
+            <a:avLst/>
+          </a:prstGeom>
+          <a:noFill/>
+          <a:ln/>
+        </p:spPr>
+        <p:txBody>
+          <a:bodyPr wrap="square" lIns="0" tIns="0" rIns="0" bIns="0" rtlCol="0" anchor="ctr"/>
+          <a:lstStyle/>
+          <a:p>
+            <a:pPr algn="l" indent="0" marL="0">
+              <a:buNone/>
+            </a:pPr>
+            <a:r>
+              <a:rPr lang="en-US" sz="900" dirty="0">
+                <a:solidFill>
+                  <a:srgbClr val="9AA3D8"/>
+                </a:solidFill>
+                <a:latin typeface="Calibri" pitchFamily="34" charset="0"/>
+                <a:ea typeface="Calibri" pitchFamily="34" charset="-122"/>
+                <a:cs typeface="Calibri" pitchFamily="34" charset="-120"/>
+              </a:rPr>
+              <a:t>Usman Akram  •  COMSATS University Islamabad</a:t>
+            </a:r>
+            <a:endParaRPr lang="en-US" sz="900" dirty="0"/>
+          </a:p>
+        </p:txBody>
+      </p:sp>
+      <p:sp>
+        <p:nvSpPr>
+          <p:cNvPr id="13" name="Text 11"/>
+          <p:cNvSpPr txBox="1"/>
+          <p:nvPr/>
+        </p:nvSpPr>
+        <p:spPr>
+          <a:xfrm>
+            <a:off x="11155680" y="6446520"/>
+            <a:ext cx="457200" cy="292608"/>
+          </a:xfrm>
+          <a:prstGeom prst="rect">
+            <a:avLst/>
+          </a:prstGeom>
+          <a:noFill/>
+          <a:ln/>
+        </p:spPr>
+        <p:txBody>
+          <a:bodyPr wrap="square" lIns="0" tIns="0" rIns="0" bIns="0" rtlCol="0" anchor="ctr"/>
+          <a:lstStyle/>
+          <a:p>
+            <a:pPr algn="r" indent="0" marL="0">
+              <a:buNone/>
+            </a:pPr>
+            <a:r>
+              <a:rPr lang="en-US" sz="900" dirty="0">
+                <a:solidFill>
+                  <a:srgbClr val="9AA3D8"/>
+                </a:solidFill>
+                <a:latin typeface="Calibri" pitchFamily="34" charset="0"/>
+                <a:ea typeface="Calibri" pitchFamily="34" charset="-122"/>
+                <a:cs typeface="Calibri" pitchFamily="34" charset="-120"/>
+              </a:rPr>
+              <a:t>1</a:t>
+            </a:r>
+            <a:endParaRPr lang="en-US" sz="900" dirty="0"/>
           </a:p>
         </p:txBody>
       </p:sp>
@@ -2576,7 +2654,7 @@
         <p:spPr>
           <a:xfrm>
             <a:off x="640080" y="457200"/>
-            <a:ext cx="9144000" cy="365760"/>
+            <a:ext cx="10058400" cy="365760"/>
           </a:xfrm>
           <a:prstGeom prst="rect">
             <a:avLst/>
@@ -3268,8 +3346,8 @@
         </p:nvSpPr>
         <p:spPr>
           <a:xfrm>
-            <a:off x="640080" y="6419088"/>
-            <a:ext cx="7315200" cy="320040"/>
+            <a:off x="640080" y="6446520"/>
+            <a:ext cx="8686800" cy="292608"/>
           </a:xfrm>
           <a:prstGeom prst="rect">
             <a:avLst/>
@@ -3293,7 +3371,7 @@
                 <a:ea typeface="Calibri" pitchFamily="34" charset="-122"/>
                 <a:cs typeface="Calibri" pitchFamily="34" charset="-120"/>
               </a:rPr>
-              <a:t>CSC336 Web Technologies  •  Lecture 1</a:t>
+              <a:t>Usman Akram  •  COMSATS University Islamabad</a:t>
             </a:r>
             <a:endParaRPr lang="en-US" sz="900" dirty="0"/>
           </a:p>
@@ -3307,8 +3385,8 @@
         </p:nvSpPr>
         <p:spPr>
           <a:xfrm>
-            <a:off x="11155680" y="6419088"/>
-            <a:ext cx="457200" cy="320040"/>
+            <a:off x="11155680" y="6446520"/>
+            <a:ext cx="457200" cy="292608"/>
           </a:xfrm>
           <a:prstGeom prst="rect">
             <a:avLst/>
@@ -3379,7 +3457,7 @@
         <p:spPr>
           <a:xfrm>
             <a:off x="640080" y="457200"/>
-            <a:ext cx="9144000" cy="365760"/>
+            <a:ext cx="10058400" cy="365760"/>
           </a:xfrm>
           <a:prstGeom prst="rect">
             <a:avLst/>
@@ -4151,8 +4229,8 @@
         </p:nvSpPr>
         <p:spPr>
           <a:xfrm>
-            <a:off x="640080" y="6419088"/>
-            <a:ext cx="7315200" cy="320040"/>
+            <a:off x="640080" y="6446520"/>
+            <a:ext cx="8686800" cy="292608"/>
           </a:xfrm>
           <a:prstGeom prst="rect">
             <a:avLst/>
@@ -4176,7 +4254,7 @@
                 <a:ea typeface="Calibri" pitchFamily="34" charset="-122"/>
                 <a:cs typeface="Calibri" pitchFamily="34" charset="-120"/>
               </a:rPr>
-              <a:t>CSC336 Web Technologies  •  Lecture 1</a:t>
+              <a:t>Usman Akram  •  COMSATS University Islamabad</a:t>
             </a:r>
             <a:endParaRPr lang="en-US" sz="900" dirty="0"/>
           </a:p>
@@ -4190,8 +4268,8 @@
         </p:nvSpPr>
         <p:spPr>
           <a:xfrm>
-            <a:off x="11155680" y="6419088"/>
-            <a:ext cx="457200" cy="320040"/>
+            <a:off x="11155680" y="6446520"/>
+            <a:ext cx="457200" cy="292608"/>
           </a:xfrm>
           <a:prstGeom prst="rect">
             <a:avLst/>
@@ -4262,7 +4340,7 @@
         <p:spPr>
           <a:xfrm>
             <a:off x="640080" y="457200"/>
-            <a:ext cx="9144000" cy="365760"/>
+            <a:ext cx="10058400" cy="365760"/>
           </a:xfrm>
           <a:prstGeom prst="rect">
             <a:avLst/>
@@ -5780,8 +5858,8 @@
         </p:nvSpPr>
         <p:spPr>
           <a:xfrm>
-            <a:off x="640080" y="6419088"/>
-            <a:ext cx="7315200" cy="320040"/>
+            <a:off x="640080" y="6446520"/>
+            <a:ext cx="8686800" cy="292608"/>
           </a:xfrm>
           <a:prstGeom prst="rect">
             <a:avLst/>
@@ -5805,7 +5883,7 @@
                 <a:ea typeface="Calibri" pitchFamily="34" charset="-122"/>
                 <a:cs typeface="Calibri" pitchFamily="34" charset="-120"/>
               </a:rPr>
-              <a:t>CSC336 Web Technologies  •  Lecture 1</a:t>
+              <a:t>Usman Akram  •  COMSATS University Islamabad</a:t>
             </a:r>
             <a:endParaRPr lang="en-US" sz="900" dirty="0"/>
           </a:p>
@@ -5819,8 +5897,8 @@
         </p:nvSpPr>
         <p:spPr>
           <a:xfrm>
-            <a:off x="11155680" y="6419088"/>
-            <a:ext cx="457200" cy="320040"/>
+            <a:off x="11155680" y="6446520"/>
+            <a:ext cx="457200" cy="292608"/>
           </a:xfrm>
           <a:prstGeom prst="rect">
             <a:avLst/>
@@ -5891,7 +5969,7 @@
         <p:spPr>
           <a:xfrm>
             <a:off x="640080" y="457200"/>
-            <a:ext cx="9144000" cy="365760"/>
+            <a:ext cx="10058400" cy="365760"/>
           </a:xfrm>
           <a:prstGeom prst="rect">
             <a:avLst/>
@@ -6394,8 +6472,8 @@
         </p:nvSpPr>
         <p:spPr>
           <a:xfrm>
-            <a:off x="640080" y="6419088"/>
-            <a:ext cx="7315200" cy="320040"/>
+            <a:off x="640080" y="6446520"/>
+            <a:ext cx="8686800" cy="292608"/>
           </a:xfrm>
           <a:prstGeom prst="rect">
             <a:avLst/>
@@ -6419,7 +6497,7 @@
                 <a:ea typeface="Calibri" pitchFamily="34" charset="-122"/>
                 <a:cs typeface="Calibri" pitchFamily="34" charset="-120"/>
               </a:rPr>
-              <a:t>CSC336 Web Technologies  •  Lecture 1</a:t>
+              <a:t>Usman Akram  •  COMSATS University Islamabad</a:t>
             </a:r>
             <a:endParaRPr lang="en-US" sz="900" dirty="0"/>
           </a:p>
@@ -6433,8 +6511,8 @@
         </p:nvSpPr>
         <p:spPr>
           <a:xfrm>
-            <a:off x="11155680" y="6419088"/>
-            <a:ext cx="457200" cy="320040"/>
+            <a:off x="11155680" y="6446520"/>
+            <a:ext cx="457200" cy="292608"/>
           </a:xfrm>
           <a:prstGeom prst="rect">
             <a:avLst/>
@@ -6505,7 +6583,7 @@
         <p:spPr>
           <a:xfrm>
             <a:off x="640080" y="457200"/>
-            <a:ext cx="9144000" cy="365760"/>
+            <a:ext cx="10058400" cy="365760"/>
           </a:xfrm>
           <a:prstGeom prst="rect">
             <a:avLst/>
@@ -7446,8 +7524,8 @@
         </p:nvSpPr>
         <p:spPr>
           <a:xfrm>
-            <a:off x="640080" y="6419088"/>
-            <a:ext cx="7315200" cy="320040"/>
+            <a:off x="640080" y="6446520"/>
+            <a:ext cx="8686800" cy="292608"/>
           </a:xfrm>
           <a:prstGeom prst="rect">
             <a:avLst/>
@@ -7471,7 +7549,7 @@
                 <a:ea typeface="Calibri" pitchFamily="34" charset="-122"/>
                 <a:cs typeface="Calibri" pitchFamily="34" charset="-120"/>
               </a:rPr>
-              <a:t>CSC336 Web Technologies  •  Lecture 1</a:t>
+              <a:t>Usman Akram  •  COMSATS University Islamabad</a:t>
             </a:r>
             <a:endParaRPr lang="en-US" sz="900" dirty="0"/>
           </a:p>
@@ -7485,8 +7563,8 @@
         </p:nvSpPr>
         <p:spPr>
           <a:xfrm>
-            <a:off x="11155680" y="6419088"/>
-            <a:ext cx="457200" cy="320040"/>
+            <a:off x="11155680" y="6446520"/>
+            <a:ext cx="457200" cy="292608"/>
           </a:xfrm>
           <a:prstGeom prst="rect">
             <a:avLst/>
@@ -7557,7 +7635,7 @@
         <p:spPr>
           <a:xfrm>
             <a:off x="640080" y="457200"/>
-            <a:ext cx="9144000" cy="365760"/>
+            <a:ext cx="10058400" cy="365760"/>
           </a:xfrm>
           <a:prstGeom prst="rect">
             <a:avLst/>
@@ -8212,8 +8290,8 @@
         </p:nvSpPr>
         <p:spPr>
           <a:xfrm>
-            <a:off x="640080" y="6419088"/>
-            <a:ext cx="7315200" cy="320040"/>
+            <a:off x="640080" y="6446520"/>
+            <a:ext cx="8686800" cy="292608"/>
           </a:xfrm>
           <a:prstGeom prst="rect">
             <a:avLst/>
@@ -8237,7 +8315,7 @@
                 <a:ea typeface="Calibri" pitchFamily="34" charset="-122"/>
                 <a:cs typeface="Calibri" pitchFamily="34" charset="-120"/>
               </a:rPr>
-              <a:t>CSC336 Web Technologies  •  Lecture 1</a:t>
+              <a:t>Usman Akram  •  COMSATS University Islamabad</a:t>
             </a:r>
             <a:endParaRPr lang="en-US" sz="900" dirty="0"/>
           </a:p>
@@ -8251,8 +8329,8 @@
         </p:nvSpPr>
         <p:spPr>
           <a:xfrm>
-            <a:off x="11155680" y="6419088"/>
-            <a:ext cx="457200" cy="320040"/>
+            <a:off x="11155680" y="6446520"/>
+            <a:ext cx="457200" cy="292608"/>
           </a:xfrm>
           <a:prstGeom prst="rect">
             <a:avLst/>
@@ -8980,6 +9058,84 @@
           </a:p>
         </p:txBody>
       </p:sp>
+      <p:sp>
+        <p:nvSpPr>
+          <p:cNvPr id="22" name="Text 20"/>
+          <p:cNvSpPr txBox="1"/>
+          <p:nvPr/>
+        </p:nvSpPr>
+        <p:spPr>
+          <a:xfrm>
+            <a:off x="640080" y="6446520"/>
+            <a:ext cx="8686800" cy="292608"/>
+          </a:xfrm>
+          <a:prstGeom prst="rect">
+            <a:avLst/>
+          </a:prstGeom>
+          <a:noFill/>
+          <a:ln/>
+        </p:spPr>
+        <p:txBody>
+          <a:bodyPr wrap="square" lIns="0" tIns="0" rIns="0" bIns="0" rtlCol="0" anchor="ctr"/>
+          <a:lstStyle/>
+          <a:p>
+            <a:pPr algn="l" indent="0" marL="0">
+              <a:buNone/>
+            </a:pPr>
+            <a:r>
+              <a:rPr lang="en-US" sz="900" dirty="0">
+                <a:solidFill>
+                  <a:srgbClr val="9AA3D8"/>
+                </a:solidFill>
+                <a:latin typeface="Calibri" pitchFamily="34" charset="0"/>
+                <a:ea typeface="Calibri" pitchFamily="34" charset="-122"/>
+                <a:cs typeface="Calibri" pitchFamily="34" charset="-120"/>
+              </a:rPr>
+              <a:t>Usman Akram  •  COMSATS University Islamabad</a:t>
+            </a:r>
+            <a:endParaRPr lang="en-US" sz="900" dirty="0"/>
+          </a:p>
+        </p:txBody>
+      </p:sp>
+      <p:sp>
+        <p:nvSpPr>
+          <p:cNvPr id="23" name="Text 21"/>
+          <p:cNvSpPr txBox="1"/>
+          <p:nvPr/>
+        </p:nvSpPr>
+        <p:spPr>
+          <a:xfrm>
+            <a:off x="11155680" y="6446520"/>
+            <a:ext cx="457200" cy="292608"/>
+          </a:xfrm>
+          <a:prstGeom prst="rect">
+            <a:avLst/>
+          </a:prstGeom>
+          <a:noFill/>
+          <a:ln/>
+        </p:spPr>
+        <p:txBody>
+          <a:bodyPr wrap="square" lIns="0" tIns="0" rIns="0" bIns="0" rtlCol="0" anchor="ctr"/>
+          <a:lstStyle/>
+          <a:p>
+            <a:pPr algn="r" indent="0" marL="0">
+              <a:buNone/>
+            </a:pPr>
+            <a:r>
+              <a:rPr lang="en-US" sz="900" dirty="0">
+                <a:solidFill>
+                  <a:srgbClr val="9AA3D8"/>
+                </a:solidFill>
+                <a:latin typeface="Calibri" pitchFamily="34" charset="0"/>
+                <a:ea typeface="Calibri" pitchFamily="34" charset="-122"/>
+                <a:cs typeface="Calibri" pitchFamily="34" charset="-120"/>
+              </a:rPr>
+              <a:t>16</a:t>
+            </a:r>
+            <a:endParaRPr lang="en-US" sz="900" dirty="0"/>
+          </a:p>
+        </p:txBody>
+      </p:sp>
     </p:spTree>
   </p:cSld>
   <p:clrMapOvr>
@@ -9021,7 +9177,7 @@
         <p:spPr>
           <a:xfrm>
             <a:off x="640080" y="457200"/>
-            <a:ext cx="9144000" cy="365760"/>
+            <a:ext cx="10058400" cy="365760"/>
           </a:xfrm>
           <a:prstGeom prst="rect">
             <a:avLst/>
@@ -9686,8 +9842,8 @@
         </p:nvSpPr>
         <p:spPr>
           <a:xfrm>
-            <a:off x="640080" y="6419088"/>
-            <a:ext cx="7315200" cy="320040"/>
+            <a:off x="640080" y="6446520"/>
+            <a:ext cx="8686800" cy="292608"/>
           </a:xfrm>
           <a:prstGeom prst="rect">
             <a:avLst/>
@@ -9711,7 +9867,7 @@
                 <a:ea typeface="Calibri" pitchFamily="34" charset="-122"/>
                 <a:cs typeface="Calibri" pitchFamily="34" charset="-120"/>
               </a:rPr>
-              <a:t>CSC336 Web Technologies  •  Lecture 1</a:t>
+              <a:t>Usman Akram  •  COMSATS University Islamabad</a:t>
             </a:r>
             <a:endParaRPr lang="en-US" sz="900" dirty="0"/>
           </a:p>
@@ -9725,8 +9881,8 @@
         </p:nvSpPr>
         <p:spPr>
           <a:xfrm>
-            <a:off x="11155680" y="6419088"/>
-            <a:ext cx="457200" cy="320040"/>
+            <a:off x="11155680" y="6446520"/>
+            <a:ext cx="457200" cy="292608"/>
           </a:xfrm>
           <a:prstGeom prst="rect">
             <a:avLst/>
@@ -9797,7 +9953,7 @@
         <p:spPr>
           <a:xfrm>
             <a:off x="640080" y="457200"/>
-            <a:ext cx="9144000" cy="365760"/>
+            <a:ext cx="10058400" cy="365760"/>
           </a:xfrm>
           <a:prstGeom prst="rect">
             <a:avLst/>
@@ -10257,8 +10413,8 @@
         </p:nvSpPr>
         <p:spPr>
           <a:xfrm>
-            <a:off x="640080" y="6419088"/>
-            <a:ext cx="7315200" cy="320040"/>
+            <a:off x="640080" y="6446520"/>
+            <a:ext cx="8686800" cy="292608"/>
           </a:xfrm>
           <a:prstGeom prst="rect">
             <a:avLst/>
@@ -10282,7 +10438,7 @@
                 <a:ea typeface="Calibri" pitchFamily="34" charset="-122"/>
                 <a:cs typeface="Calibri" pitchFamily="34" charset="-120"/>
               </a:rPr>
-              <a:t>CSC336 Web Technologies  •  Lecture 1</a:t>
+              <a:t>Usman Akram  •  COMSATS University Islamabad</a:t>
             </a:r>
             <a:endParaRPr lang="en-US" sz="900" dirty="0"/>
           </a:p>
@@ -10296,8 +10452,8 @@
         </p:nvSpPr>
         <p:spPr>
           <a:xfrm>
-            <a:off x="11155680" y="6419088"/>
-            <a:ext cx="457200" cy="320040"/>
+            <a:off x="11155680" y="6446520"/>
+            <a:ext cx="457200" cy="292608"/>
           </a:xfrm>
           <a:prstGeom prst="rect">
             <a:avLst/>
@@ -10368,7 +10524,7 @@
         <p:spPr>
           <a:xfrm>
             <a:off x="640080" y="457200"/>
-            <a:ext cx="9144000" cy="365760"/>
+            <a:ext cx="10058400" cy="365760"/>
           </a:xfrm>
           <a:prstGeom prst="rect">
             <a:avLst/>
@@ -11054,8 +11210,8 @@
         </p:nvSpPr>
         <p:spPr>
           <a:xfrm>
-            <a:off x="640080" y="6419088"/>
-            <a:ext cx="7315200" cy="320040"/>
+            <a:off x="640080" y="6446520"/>
+            <a:ext cx="8686800" cy="292608"/>
           </a:xfrm>
           <a:prstGeom prst="rect">
             <a:avLst/>
@@ -11079,7 +11235,7 @@
                 <a:ea typeface="Calibri" pitchFamily="34" charset="-122"/>
                 <a:cs typeface="Calibri" pitchFamily="34" charset="-120"/>
               </a:rPr>
-              <a:t>CSC336 Web Technologies  •  Lecture 1</a:t>
+              <a:t>Usman Akram  •  COMSATS University Islamabad</a:t>
             </a:r>
             <a:endParaRPr lang="en-US" sz="900" dirty="0"/>
           </a:p>
@@ -11093,8 +11249,8 @@
         </p:nvSpPr>
         <p:spPr>
           <a:xfrm>
-            <a:off x="11155680" y="6419088"/>
-            <a:ext cx="457200" cy="320040"/>
+            <a:off x="11155680" y="6446520"/>
+            <a:ext cx="457200" cy="292608"/>
           </a:xfrm>
           <a:prstGeom prst="rect">
             <a:avLst/>
@@ -11165,7 +11321,7 @@
         <p:spPr>
           <a:xfrm>
             <a:off x="640080" y="457200"/>
-            <a:ext cx="9144000" cy="365760"/>
+            <a:ext cx="10058400" cy="365760"/>
           </a:xfrm>
           <a:prstGeom prst="rect">
             <a:avLst/>
@@ -11732,8 +11888,8 @@
         </p:nvSpPr>
         <p:spPr>
           <a:xfrm>
-            <a:off x="640080" y="6419088"/>
-            <a:ext cx="7315200" cy="320040"/>
+            <a:off x="640080" y="6446520"/>
+            <a:ext cx="8686800" cy="292608"/>
           </a:xfrm>
           <a:prstGeom prst="rect">
             <a:avLst/>
@@ -11757,7 +11913,7 @@
                 <a:ea typeface="Calibri" pitchFamily="34" charset="-122"/>
                 <a:cs typeface="Calibri" pitchFamily="34" charset="-120"/>
               </a:rPr>
-              <a:t>CSC336 Web Technologies  •  Lecture 1</a:t>
+              <a:t>Usman Akram  •  COMSATS University Islamabad</a:t>
             </a:r>
             <a:endParaRPr lang="en-US" sz="900" dirty="0"/>
           </a:p>
@@ -11771,8 +11927,8 @@
         </p:nvSpPr>
         <p:spPr>
           <a:xfrm>
-            <a:off x="11155680" y="6419088"/>
-            <a:ext cx="457200" cy="320040"/>
+            <a:off x="11155680" y="6446520"/>
+            <a:ext cx="457200" cy="292608"/>
           </a:xfrm>
           <a:prstGeom prst="rect">
             <a:avLst/>
@@ -11843,7 +11999,7 @@
         <p:spPr>
           <a:xfrm>
             <a:off x="640080" y="457200"/>
-            <a:ext cx="9144000" cy="365760"/>
+            <a:ext cx="10058400" cy="365760"/>
           </a:xfrm>
           <a:prstGeom prst="rect">
             <a:avLst/>
@@ -12722,8 +12878,8 @@
         </p:nvSpPr>
         <p:spPr>
           <a:xfrm>
-            <a:off x="640080" y="6419088"/>
-            <a:ext cx="7315200" cy="320040"/>
+            <a:off x="640080" y="6446520"/>
+            <a:ext cx="8686800" cy="292608"/>
           </a:xfrm>
           <a:prstGeom prst="rect">
             <a:avLst/>
@@ -12747,7 +12903,7 @@
                 <a:ea typeface="Calibri" pitchFamily="34" charset="-122"/>
                 <a:cs typeface="Calibri" pitchFamily="34" charset="-120"/>
               </a:rPr>
-              <a:t>CSC336 Web Technologies  •  Lecture 1</a:t>
+              <a:t>Usman Akram  •  COMSATS University Islamabad</a:t>
             </a:r>
             <a:endParaRPr lang="en-US" sz="900" dirty="0"/>
           </a:p>
@@ -12761,8 +12917,8 @@
         </p:nvSpPr>
         <p:spPr>
           <a:xfrm>
-            <a:off x="11155680" y="6419088"/>
-            <a:ext cx="457200" cy="320040"/>
+            <a:off x="11155680" y="6446520"/>
+            <a:ext cx="457200" cy="292608"/>
           </a:xfrm>
           <a:prstGeom prst="rect">
             <a:avLst/>
@@ -12833,7 +12989,7 @@
         <p:spPr>
           <a:xfrm>
             <a:off x="640080" y="457200"/>
-            <a:ext cx="9144000" cy="365760"/>
+            <a:ext cx="10058400" cy="365760"/>
           </a:xfrm>
           <a:prstGeom prst="rect">
             <a:avLst/>
@@ -13278,8 +13434,8 @@
         </p:nvSpPr>
         <p:spPr>
           <a:xfrm>
-            <a:off x="640080" y="6419088"/>
-            <a:ext cx="7315200" cy="320040"/>
+            <a:off x="640080" y="6446520"/>
+            <a:ext cx="8686800" cy="292608"/>
           </a:xfrm>
           <a:prstGeom prst="rect">
             <a:avLst/>
@@ -13303,7 +13459,7 @@
                 <a:ea typeface="Calibri" pitchFamily="34" charset="-122"/>
                 <a:cs typeface="Calibri" pitchFamily="34" charset="-120"/>
               </a:rPr>
-              <a:t>CSC336 Web Technologies  •  Lecture 1</a:t>
+              <a:t>Usman Akram  •  COMSATS University Islamabad</a:t>
             </a:r>
             <a:endParaRPr lang="en-US" sz="900" dirty="0"/>
           </a:p>
@@ -13317,8 +13473,8 @@
         </p:nvSpPr>
         <p:spPr>
           <a:xfrm>
-            <a:off x="11155680" y="6419088"/>
-            <a:ext cx="457200" cy="320040"/>
+            <a:off x="11155680" y="6446520"/>
+            <a:ext cx="457200" cy="292608"/>
           </a:xfrm>
           <a:prstGeom prst="rect">
             <a:avLst/>
@@ -13389,7 +13545,7 @@
         <p:spPr>
           <a:xfrm>
             <a:off x="640080" y="457200"/>
-            <a:ext cx="9144000" cy="365760"/>
+            <a:ext cx="10058400" cy="365760"/>
           </a:xfrm>
           <a:prstGeom prst="rect">
             <a:avLst/>
@@ -14078,8 +14234,8 @@
         </p:nvSpPr>
         <p:spPr>
           <a:xfrm>
-            <a:off x="640080" y="6419088"/>
-            <a:ext cx="7315200" cy="320040"/>
+            <a:off x="640080" y="6446520"/>
+            <a:ext cx="8686800" cy="292608"/>
           </a:xfrm>
           <a:prstGeom prst="rect">
             <a:avLst/>
@@ -14103,7 +14259,7 @@
                 <a:ea typeface="Calibri" pitchFamily="34" charset="-122"/>
                 <a:cs typeface="Calibri" pitchFamily="34" charset="-120"/>
               </a:rPr>
-              <a:t>CSC336 Web Technologies  •  Lecture 1</a:t>
+              <a:t>Usman Akram  •  COMSATS University Islamabad</a:t>
             </a:r>
             <a:endParaRPr lang="en-US" sz="900" dirty="0"/>
           </a:p>
@@ -14117,8 +14273,8 @@
         </p:nvSpPr>
         <p:spPr>
           <a:xfrm>
-            <a:off x="11155680" y="6419088"/>
-            <a:ext cx="457200" cy="320040"/>
+            <a:off x="11155680" y="6446520"/>
+            <a:ext cx="457200" cy="292608"/>
           </a:xfrm>
           <a:prstGeom prst="rect">
             <a:avLst/>
@@ -14189,7 +14345,7 @@
         <p:spPr>
           <a:xfrm>
             <a:off x="640080" y="457200"/>
-            <a:ext cx="9144000" cy="365760"/>
+            <a:ext cx="10058400" cy="365760"/>
           </a:xfrm>
           <a:prstGeom prst="rect">
             <a:avLst/>
@@ -14698,8 +14854,8 @@
         </p:nvSpPr>
         <p:spPr>
           <a:xfrm>
-            <a:off x="640080" y="6419088"/>
-            <a:ext cx="7315200" cy="320040"/>
+            <a:off x="640080" y="6446520"/>
+            <a:ext cx="8686800" cy="292608"/>
           </a:xfrm>
           <a:prstGeom prst="rect">
             <a:avLst/>
@@ -14723,7 +14879,7 @@
                 <a:ea typeface="Calibri" pitchFamily="34" charset="-122"/>
                 <a:cs typeface="Calibri" pitchFamily="34" charset="-120"/>
               </a:rPr>
-              <a:t>CSC336 Web Technologies  •  Lecture 1</a:t>
+              <a:t>Usman Akram  •  COMSATS University Islamabad</a:t>
             </a:r>
             <a:endParaRPr lang="en-US" sz="900" dirty="0"/>
           </a:p>
@@ -14737,8 +14893,8 @@
         </p:nvSpPr>
         <p:spPr>
           <a:xfrm>
-            <a:off x="11155680" y="6419088"/>
-            <a:ext cx="457200" cy="320040"/>
+            <a:off x="11155680" y="6446520"/>
+            <a:ext cx="457200" cy="292608"/>
           </a:xfrm>
           <a:prstGeom prst="rect">
             <a:avLst/>

</xml_diff>